<commit_message>
vault backup: 2026-06-03 16:39:52
</commit_message>
<xml_diff>
--- a/抗量子密码/论文汇报/汇报模板.pptx
+++ b/抗量子密码/论文汇报/汇报模板.pptx
@@ -213,7 +213,7 @@
           <a:p>
             <a:fld id="{AFE62296-9383-4CE2-B089-9B1D81D14FA7}" type="datetimeFigureOut">
               <a:rPr lang="zh-CN" altLang="en-US" smtClean="0"/>
-              <a:t>2025/12/3</a:t>
+              <a:t>2026/6/3</a:t>
             </a:fld>
             <a:endParaRPr lang="zh-CN" altLang="en-US"/>
           </a:p>
@@ -1648,7 +1648,7 @@
           <a:p>
             <a:fld id="{F33FDE0E-32F9-4681-B932-59D96D5EEB4E}" type="datetimeFigureOut">
               <a:rPr lang="zh-CN" altLang="en-US" smtClean="0"/>
-              <a:t>2025/12/3</a:t>
+              <a:t>2026/6/3</a:t>
             </a:fld>
             <a:endParaRPr lang="zh-CN" altLang="en-US"/>
           </a:p>
@@ -1846,7 +1846,7 @@
           <a:p>
             <a:fld id="{F33FDE0E-32F9-4681-B932-59D96D5EEB4E}" type="datetimeFigureOut">
               <a:rPr lang="zh-CN" altLang="en-US" smtClean="0"/>
-              <a:t>2025/12/3</a:t>
+              <a:t>2026/6/3</a:t>
             </a:fld>
             <a:endParaRPr lang="zh-CN" altLang="en-US"/>
           </a:p>
@@ -2054,7 +2054,7 @@
           <a:p>
             <a:fld id="{F33FDE0E-32F9-4681-B932-59D96D5EEB4E}" type="datetimeFigureOut">
               <a:rPr lang="zh-CN" altLang="en-US" smtClean="0"/>
-              <a:t>2025/12/3</a:t>
+              <a:t>2026/6/3</a:t>
             </a:fld>
             <a:endParaRPr lang="zh-CN" altLang="en-US"/>
           </a:p>
@@ -2252,7 +2252,7 @@
           <a:p>
             <a:fld id="{F33FDE0E-32F9-4681-B932-59D96D5EEB4E}" type="datetimeFigureOut">
               <a:rPr lang="zh-CN" altLang="en-US" smtClean="0"/>
-              <a:t>2025/12/3</a:t>
+              <a:t>2026/6/3</a:t>
             </a:fld>
             <a:endParaRPr lang="zh-CN" altLang="en-US"/>
           </a:p>
@@ -2527,7 +2527,7 @@
           <a:p>
             <a:fld id="{F33FDE0E-32F9-4681-B932-59D96D5EEB4E}" type="datetimeFigureOut">
               <a:rPr lang="zh-CN" altLang="en-US" smtClean="0"/>
-              <a:t>2025/12/3</a:t>
+              <a:t>2026/6/3</a:t>
             </a:fld>
             <a:endParaRPr lang="zh-CN" altLang="en-US"/>
           </a:p>
@@ -2792,7 +2792,7 @@
           <a:p>
             <a:fld id="{F33FDE0E-32F9-4681-B932-59D96D5EEB4E}" type="datetimeFigureOut">
               <a:rPr lang="zh-CN" altLang="en-US" smtClean="0"/>
-              <a:t>2025/12/3</a:t>
+              <a:t>2026/6/3</a:t>
             </a:fld>
             <a:endParaRPr lang="zh-CN" altLang="en-US"/>
           </a:p>
@@ -3204,7 +3204,7 @@
           <a:p>
             <a:fld id="{F33FDE0E-32F9-4681-B932-59D96D5EEB4E}" type="datetimeFigureOut">
               <a:rPr lang="zh-CN" altLang="en-US" smtClean="0"/>
-              <a:t>2025/12/3</a:t>
+              <a:t>2026/6/3</a:t>
             </a:fld>
             <a:endParaRPr lang="zh-CN" altLang="en-US"/>
           </a:p>
@@ -3345,7 +3345,7 @@
           <a:p>
             <a:fld id="{F33FDE0E-32F9-4681-B932-59D96D5EEB4E}" type="datetimeFigureOut">
               <a:rPr lang="zh-CN" altLang="en-US" smtClean="0"/>
-              <a:t>2025/12/3</a:t>
+              <a:t>2026/6/3</a:t>
             </a:fld>
             <a:endParaRPr lang="zh-CN" altLang="en-US"/>
           </a:p>
@@ -3458,7 +3458,7 @@
           <a:p>
             <a:fld id="{F33FDE0E-32F9-4681-B932-59D96D5EEB4E}" type="datetimeFigureOut">
               <a:rPr lang="zh-CN" altLang="en-US" smtClean="0"/>
-              <a:t>2025/12/3</a:t>
+              <a:t>2026/6/3</a:t>
             </a:fld>
             <a:endParaRPr lang="zh-CN" altLang="en-US"/>
           </a:p>
@@ -3769,7 +3769,7 @@
           <a:p>
             <a:fld id="{F33FDE0E-32F9-4681-B932-59D96D5EEB4E}" type="datetimeFigureOut">
               <a:rPr lang="zh-CN" altLang="en-US" smtClean="0"/>
-              <a:t>2025/12/3</a:t>
+              <a:t>2026/6/3</a:t>
             </a:fld>
             <a:endParaRPr lang="zh-CN" altLang="en-US"/>
           </a:p>
@@ -4057,7 +4057,7 @@
           <a:p>
             <a:fld id="{F33FDE0E-32F9-4681-B932-59D96D5EEB4E}" type="datetimeFigureOut">
               <a:rPr lang="zh-CN" altLang="en-US" smtClean="0"/>
-              <a:t>2025/12/3</a:t>
+              <a:t>2026/6/3</a:t>
             </a:fld>
             <a:endParaRPr lang="zh-CN" altLang="en-US"/>
           </a:p>
@@ -4298,7 +4298,7 @@
           <a:p>
             <a:fld id="{F33FDE0E-32F9-4681-B932-59D96D5EEB4E}" type="datetimeFigureOut">
               <a:rPr lang="zh-CN" altLang="en-US" smtClean="0"/>
-              <a:t>2025/12/3</a:t>
+              <a:t>2026/6/3</a:t>
             </a:fld>
             <a:endParaRPr lang="zh-CN" altLang="en-US"/>
           </a:p>
@@ -4916,8 +4916,8 @@
         </p:nvSpPr>
         <p:spPr>
           <a:xfrm>
-            <a:off x="3966470" y="4106923"/>
-            <a:ext cx="4977036" cy="923330"/>
+            <a:off x="2774265" y="4056123"/>
+            <a:ext cx="6687016" cy="923330"/>
           </a:xfrm>
           <a:prstGeom prst="rect">
             <a:avLst/>
@@ -4962,7 +4962,7 @@
                 <a:ea typeface="Microsoft YaHei Light" panose="020B0502040204020203" pitchFamily="34" charset="-122"/>
                 <a:cs typeface="+mn-cs"/>
               </a:rPr>
-              <a:t>李子恒    </a:t>
+              <a:t>密码与网络空间安全学院  李子恒    </a:t>
             </a:r>
             <a:r>
               <a:rPr kumimoji="0" lang="en-US" altLang="zh-CN" sz="1800" b="0" i="0" u="none" strike="noStrike" kern="1200" cap="none" spc="0" normalizeH="0" baseline="0" noProof="0" dirty="0">
@@ -4996,7 +4996,7 @@
                 <a:ea typeface="Microsoft YaHei Light" panose="020B0502040204020203" pitchFamily="34" charset="-122"/>
                 <a:cs typeface="+mn-cs"/>
               </a:rPr>
-              <a:t>密码与网络空间安全学院</a:t>
+              <a:t>方法与创新</a:t>
             </a:r>
             <a:endParaRPr kumimoji="0" lang="en-US" altLang="zh-CN" sz="1800" b="0" i="0" u="none" strike="noStrike" kern="1200" cap="none" spc="0" normalizeH="0" baseline="0" noProof="0" dirty="0">
               <a:ln>
@@ -5039,7 +5039,7 @@
                 <a:latin typeface="等线" panose="020F0502020204030204"/>
                 <a:ea typeface="Microsoft YaHei Light" panose="020B0502040204020203" pitchFamily="34" charset="-122"/>
               </a:rPr>
-              <a:t>陈馨颍    </a:t>
+              <a:t>密码与网络空间安全学院  邓晓川    </a:t>
             </a:r>
             <a:r>
               <a:rPr lang="en-US" altLang="zh-CN" dirty="0">
@@ -5049,7 +5049,7 @@
                 <a:latin typeface="等线" panose="020F0502020204030204"/>
                 <a:ea typeface="Microsoft YaHei Light" panose="020B0502040204020203" pitchFamily="34" charset="-122"/>
               </a:rPr>
-              <a:t>2213468     </a:t>
+              <a:t>2310908     </a:t>
             </a:r>
             <a:r>
               <a:rPr lang="zh-CN" altLang="en-US" dirty="0">
@@ -5059,7 +5059,7 @@
                 <a:latin typeface="等线" panose="020F0502020204030204"/>
                 <a:ea typeface="Microsoft YaHei Light" panose="020B0502040204020203" pitchFamily="34" charset="-122"/>
               </a:rPr>
-              <a:t>计算机学院</a:t>
+              <a:t>实验与结论</a:t>
             </a:r>
             <a:endParaRPr kumimoji="0" lang="zh-CN" altLang="en-US" sz="1800" b="0" i="0" u="none" strike="noStrike" kern="1200" cap="none" spc="0" normalizeH="0" baseline="0" noProof="0" dirty="0">
               <a:ln>
@@ -5109,7 +5109,34 @@
                 <a:ea typeface="Microsoft YaHei Light" panose="020B0502040204020203" pitchFamily="34" charset="-122"/>
                 <a:cs typeface="+mn-cs"/>
               </a:rPr>
-              <a:t>刘轩麟    </a:t>
+              <a:t>           计算机学院             </a:t>
+            </a:r>
+            <a:r>
+              <a:rPr lang="zh-CN" altLang="en-US" dirty="0">
+                <a:solidFill>
+                  <a:prstClr val="black"/>
+                </a:solidFill>
+                <a:latin typeface="等线" panose="020F0502020204030204"/>
+                <a:ea typeface="Microsoft YaHei Light" panose="020B0502040204020203" pitchFamily="34" charset="-122"/>
+              </a:rPr>
+              <a:t>蔡梓涵</a:t>
+            </a:r>
+            <a:r>
+              <a:rPr kumimoji="0" lang="zh-CN" altLang="en-US" sz="1800" b="0" i="0" u="none" strike="noStrike" kern="1200" cap="none" spc="0" normalizeH="0" baseline="0" noProof="0" dirty="0">
+                <a:ln>
+                  <a:noFill/>
+                </a:ln>
+                <a:solidFill>
+                  <a:prstClr val="black"/>
+                </a:solidFill>
+                <a:effectLst/>
+                <a:uLnTx/>
+                <a:uFillTx/>
+                <a:latin typeface="等线" panose="020F0502020204030204"/>
+                <a:ea typeface="Microsoft YaHei Light" panose="020B0502040204020203" pitchFamily="34" charset="-122"/>
+                <a:cs typeface="+mn-cs"/>
+              </a:rPr>
+              <a:t>    </a:t>
             </a:r>
             <a:r>
               <a:rPr kumimoji="0" lang="en-US" altLang="zh-CN" sz="1800" b="0" i="0" u="none" strike="noStrike" kern="1200" cap="none" spc="0" normalizeH="0" baseline="0" noProof="0" dirty="0">
@@ -5126,25 +5153,32 @@
                 <a:ea typeface="Microsoft YaHei Light" panose="020B0502040204020203" pitchFamily="34" charset="-122"/>
                 <a:cs typeface="+mn-cs"/>
               </a:rPr>
-              <a:t>2312289     </a:t>
+              <a:t>2313922     </a:t>
             </a:r>
             <a:r>
-              <a:rPr kumimoji="0" lang="zh-CN" altLang="en-US" sz="1800" b="0" i="0" u="none" strike="noStrike" kern="1200" cap="none" spc="0" normalizeH="0" baseline="0" noProof="0" dirty="0">
-                <a:ln>
-                  <a:noFill/>
-                </a:ln>
+              <a:rPr lang="zh-CN" altLang="en-US" dirty="0">
                 <a:solidFill>
                   <a:prstClr val="black"/>
                 </a:solidFill>
-                <a:effectLst/>
-                <a:uLnTx/>
-                <a:uFillTx/>
                 <a:latin typeface="等线" panose="020F0502020204030204"/>
                 <a:ea typeface="Microsoft YaHei Light" panose="020B0502040204020203" pitchFamily="34" charset="-122"/>
-                <a:cs typeface="+mn-cs"/>
               </a:rPr>
-              <a:t>计算机学院</a:t>
+              <a:t>背景与动机</a:t>
             </a:r>
+            <a:endParaRPr kumimoji="0" lang="zh-CN" altLang="en-US" sz="1800" b="0" i="0" u="none" strike="noStrike" kern="1200" cap="none" spc="0" normalizeH="0" baseline="0" noProof="0" dirty="0">
+              <a:ln>
+                <a:noFill/>
+              </a:ln>
+              <a:solidFill>
+                <a:prstClr val="black"/>
+              </a:solidFill>
+              <a:effectLst/>
+              <a:uLnTx/>
+              <a:uFillTx/>
+              <a:latin typeface="等线" panose="020F0502020204030204"/>
+              <a:ea typeface="Microsoft YaHei Light" panose="020B0502040204020203" pitchFamily="34" charset="-122"/>
+              <a:cs typeface="+mn-cs"/>
+            </a:endParaRPr>
           </a:p>
         </p:txBody>
       </p:sp>
@@ -5256,8 +5290,8 @@
         </p:nvSpPr>
         <p:spPr>
           <a:xfrm>
-            <a:off x="2507530" y="1837971"/>
-            <a:ext cx="7022969" cy="1877437"/>
+            <a:off x="892629" y="1823458"/>
+            <a:ext cx="9862456" cy="1938992"/>
           </a:xfrm>
           <a:prstGeom prst="rect">
             <a:avLst/>
@@ -5272,18 +5306,15 @@
           <a:p>
             <a:pPr algn="ctr"/>
             <a:r>
-              <a:rPr lang="en-US" altLang="zh-CN" sz="3200" b="1" dirty="0">
+              <a:rPr lang="en-US" altLang="zh-CN" sz="3200" b="1" dirty="0" err="1">
                 <a:solidFill>
                   <a:schemeClr val="bg1"/>
                 </a:solidFill>
                 <a:latin typeface="Times New Roman" panose="02020603050405020304" pitchFamily="18" charset="0"/>
                 <a:cs typeface="Times New Roman" panose="02020603050405020304" pitchFamily="18" charset="0"/>
               </a:rPr>
-              <a:t>Llumnix: Dynamic Scheduling for </a:t>
+              <a:t>Bidaw</a:t>
             </a:r>
-          </a:p>
-          <a:p>
-            <a:pPr algn="ctr"/>
             <a:r>
               <a:rPr lang="en-US" altLang="zh-CN" sz="3200" b="1" dirty="0">
                 <a:solidFill>
@@ -5292,11 +5323,8 @@
                 <a:latin typeface="Times New Roman" panose="02020603050405020304" pitchFamily="18" charset="0"/>
                 <a:cs typeface="Times New Roman" panose="02020603050405020304" pitchFamily="18" charset="0"/>
               </a:rPr>
-              <a:t> Large Language Model Serving</a:t>
+              <a:t>: Enhancing Key-Value Caching for Interactive LLM Serving via Bidirectional Computation–Storage Awareness</a:t>
             </a:r>
-          </a:p>
-          <a:p>
-            <a:pPr algn="ctr"/>
             <a:endParaRPr lang="en-US" altLang="zh-CN" sz="2800" b="1" dirty="0">
               <a:solidFill>
                 <a:schemeClr val="bg1"/>
@@ -5316,7 +5344,7 @@
                 <a:ea typeface="黑体" panose="02010609060101010101" pitchFamily="49" charset="-122"/>
                 <a:cs typeface="Times New Roman" panose="02020603050405020304" pitchFamily="18" charset="0"/>
               </a:rPr>
-              <a:t>操作系统论文研读汇报</a:t>
+              <a:t>系统前沿论文研读汇报</a:t>
             </a:r>
             <a:endParaRPr lang="en-US" altLang="zh-CN" sz="2400" b="1" dirty="0">
               <a:solidFill>

</xml_diff>